<commit_message>
Reframe intro slide as paper-to-mobile transformation
Co-Authored-By: Claude Opus 4.8 <noreply@anthropic.com>
Claude-Session: https://claude.ai/code/session_016dE2yG1tFCWxGLFDrnKxiU
</commit_message>
<xml_diff>
--- a/soutenance_stage_inventaire_cfc.pptx
+++ b/soutenance_stage_inventaire_cfc.pptx
@@ -10245,7 +10245,7 @@
                 </a:solidFill>
                 <a:latin typeface="Calibri"/>
               </a:rPr>
-              <a:t>Introduction &amp; Problématique</a:t>
+              <a:t>Introduction &amp; Contexte</a:t>
             </a:r>
           </a:p>
         </p:txBody>
@@ -11438,7 +11438,7 @@
                 </a:solidFill>
                 <a:latin typeface="Calibri"/>
               </a:rPr>
-              <a:t>Introduction &amp; Problématique</a:t>
+              <a:t>Introduction &amp; Contexte</a:t>
             </a:r>
           </a:p>
         </p:txBody>
@@ -11510,8 +11510,8 @@
         </p:nvSpPr>
         <p:spPr>
           <a:xfrm>
-            <a:off x="640080" y="1234440"/>
-            <a:ext cx="10881360" cy="731520"/>
+            <a:off x="640080" y="1188720"/>
+            <a:ext cx="10881360" cy="777240"/>
           </a:xfrm>
           <a:prstGeom prst="rect">
             <a:avLst/>
@@ -11532,7 +11532,7 @@
                 </a:solidFill>
                 <a:latin typeface="Calibri"/>
               </a:rPr>
-              <a:t>CF Consult réalise des missions d'inventaire physique pour ses clients. Aujourd'hui ce processus est entièrement manuel — fiches papier et fichiers Excel.</a:t>
+              <a:t>CF Consult réalise régulièrement des missions d'inventaire physique sur le terrain. L'objectif du projet : faire passer cette activité du papier au mobile, avec un outil moderne, rapide et intelligent.</a:t>
             </a:r>
           </a:p>
         </p:txBody>
@@ -11545,8 +11545,8 @@
         </p:nvSpPr>
         <p:spPr>
           <a:xfrm>
-            <a:off x="640080" y="2194560"/>
-            <a:ext cx="5212080" cy="3840480"/>
+            <a:off x="640080" y="2331720"/>
+            <a:ext cx="4023360" cy="3931920"/>
           </a:xfrm>
           <a:prstGeom prst="roundRect">
             <a:avLst>
@@ -11585,14 +11585,285 @@
       </p:sp>
       <p:sp>
         <p:nvSpPr>
-          <p:cNvPr id="9" name="Rounded Rectangle 8"/>
+          <p:cNvPr id="9" name="TextBox 8"/>
+          <p:cNvSpPr txBox="1"/>
+          <p:nvPr/>
+        </p:nvSpPr>
+        <p:spPr>
+          <a:xfrm>
+            <a:off x="640080" y="2468880"/>
+            <a:ext cx="4023360" cy="502920"/>
+          </a:xfrm>
+          <a:prstGeom prst="rect">
+            <a:avLst/>
+          </a:prstGeom>
+          <a:noFill/>
+        </p:spPr>
+        <p:txBody>
+          <a:bodyPr wrap="square" anchor="t">
+            <a:spAutoFit/>
+          </a:bodyPr>
+          <a:lstStyle/>
+          <a:p>
+            <a:pPr algn="ctr"/>
+            <a:r>
+              <a:rPr sz="2000" b="1" i="0">
+                <a:solidFill>
+                  <a:srgbClr val="778890"/>
+                </a:solidFill>
+                <a:latin typeface="Calibri"/>
+              </a:rPr>
+              <a:t>Hier</a:t>
+            </a:r>
+          </a:p>
+        </p:txBody>
+      </p:sp>
+      <p:sp>
+        <p:nvSpPr>
+          <p:cNvPr id="10" name="TextBox 9"/>
+          <p:cNvSpPr txBox="1"/>
+          <p:nvPr/>
+        </p:nvSpPr>
+        <p:spPr>
+          <a:xfrm>
+            <a:off x="640080" y="3063240"/>
+            <a:ext cx="4023360" cy="914400"/>
+          </a:xfrm>
+          <a:prstGeom prst="rect">
+            <a:avLst/>
+          </a:prstGeom>
+          <a:noFill/>
+        </p:spPr>
+        <p:txBody>
+          <a:bodyPr wrap="square" anchor="t">
+            <a:spAutoFit/>
+          </a:bodyPr>
+          <a:lstStyle/>
+          <a:p>
+            <a:pPr algn="ctr"/>
+            <a:r>
+              <a:rPr sz="4000" b="0" i="0">
+                <a:solidFill>
+                  <a:srgbClr val="778890"/>
+                </a:solidFill>
+                <a:latin typeface="Calibri"/>
+              </a:rPr>
+              <a:t>📋   📝   📊</a:t>
+            </a:r>
+          </a:p>
+        </p:txBody>
+      </p:sp>
+      <p:sp>
+        <p:nvSpPr>
+          <p:cNvPr id="11" name="TextBox 10"/>
+          <p:cNvSpPr txBox="1"/>
+          <p:nvPr/>
+        </p:nvSpPr>
+        <p:spPr>
+          <a:xfrm>
+            <a:off x="1005840" y="4206240"/>
+            <a:ext cx="3383280" cy="1920240"/>
+          </a:xfrm>
+          <a:prstGeom prst="rect">
+            <a:avLst/>
+          </a:prstGeom>
+          <a:noFill/>
+        </p:spPr>
+        <p:txBody>
+          <a:bodyPr wrap="square">
+            <a:spAutoFit/>
+          </a:bodyPr>
+          <a:lstStyle/>
+          <a:p>
+            <a:pPr>
+              <a:spcAft>
+                <a:spcPts val="1100"/>
+              </a:spcAft>
+            </a:pPr>
+            <a:r>
+              <a:rPr sz="1400">
+                <a:solidFill>
+                  <a:srgbClr val="1B344A"/>
+                </a:solidFill>
+                <a:latin typeface="Calibri"/>
+              </a:rPr>
+              <a:t>–  Fiches papier sur le terrain</a:t>
+            </a:r>
+          </a:p>
+          <a:p>
+            <a:pPr>
+              <a:spcAft>
+                <a:spcPts val="1100"/>
+              </a:spcAft>
+            </a:pPr>
+            <a:r>
+              <a:rPr sz="1400">
+                <a:solidFill>
+                  <a:srgbClr val="1B344A"/>
+                </a:solidFill>
+                <a:latin typeface="Calibri"/>
+              </a:rPr>
+              <a:t>–  Re-saisie manuelle sur Excel</a:t>
+            </a:r>
+          </a:p>
+          <a:p>
+            <a:pPr>
+              <a:spcAft>
+                <a:spcPts val="1100"/>
+              </a:spcAft>
+            </a:pPr>
+            <a:r>
+              <a:rPr sz="1400">
+                <a:solidFill>
+                  <a:srgbClr val="1B344A"/>
+                </a:solidFill>
+                <a:latin typeface="Calibri"/>
+              </a:rPr>
+              <a:t>–  Pas de photo ni de géolocalisation</a:t>
+            </a:r>
+          </a:p>
+          <a:p>
+            <a:pPr>
+              <a:spcAft>
+                <a:spcPts val="1100"/>
+              </a:spcAft>
+            </a:pPr>
+            <a:r>
+              <a:rPr sz="1400">
+                <a:solidFill>
+                  <a:srgbClr val="1B344A"/>
+                </a:solidFill>
+                <a:latin typeface="Calibri"/>
+              </a:rPr>
+              <a:t>–  Suivi difficile en temps réel</a:t>
+            </a:r>
+          </a:p>
+        </p:txBody>
+      </p:sp>
+      <p:sp>
+        <p:nvSpPr>
+          <p:cNvPr id="12" name="Right Arrow 11"/>
           <p:cNvSpPr/>
           <p:nvPr/>
         </p:nvSpPr>
         <p:spPr>
           <a:xfrm>
-            <a:off x="6309360" y="2194560"/>
-            <a:ext cx="5212080" cy="3840480"/>
+            <a:off x="4892040" y="3703320"/>
+            <a:ext cx="2377440" cy="1188720"/>
+          </a:xfrm>
+          <a:prstGeom prst="rightArrow">
+            <a:avLst/>
+          </a:prstGeom>
+          <a:solidFill>
+            <a:srgbClr val="5A7D2B"/>
+          </a:solidFill>
+          <a:ln>
+            <a:noFill/>
+          </a:ln>
+          <a:effectLst/>
+        </p:spPr>
+        <p:style>
+          <a:lnRef idx="1">
+            <a:schemeClr val="accent1"/>
+          </a:lnRef>
+          <a:fillRef idx="3">
+            <a:schemeClr val="accent1"/>
+          </a:fillRef>
+          <a:effectRef idx="2">
+            <a:schemeClr val="accent1"/>
+          </a:effectRef>
+          <a:fontRef idx="minor">
+            <a:schemeClr val="lt1"/>
+          </a:fontRef>
+        </p:style>
+        <p:txBody>
+          <a:bodyPr rtlCol="0" anchor="ctr"/>
+          <a:lstStyle/>
+          <a:p>
+            <a:pPr algn="ctr"/>
+          </a:p>
+        </p:txBody>
+      </p:sp>
+      <p:sp>
+        <p:nvSpPr>
+          <p:cNvPr id="13" name="TextBox 12"/>
+          <p:cNvSpPr txBox="1"/>
+          <p:nvPr/>
+        </p:nvSpPr>
+        <p:spPr>
+          <a:xfrm>
+            <a:off x="4892040" y="3703320"/>
+            <a:ext cx="2377440" cy="1188720"/>
+          </a:xfrm>
+          <a:prstGeom prst="rect">
+            <a:avLst/>
+          </a:prstGeom>
+          <a:noFill/>
+        </p:spPr>
+        <p:txBody>
+          <a:bodyPr wrap="square" anchor="ctr">
+            <a:spAutoFit/>
+          </a:bodyPr>
+          <a:lstStyle/>
+          <a:p>
+            <a:pPr algn="ctr"/>
+            <a:r>
+              <a:rPr sz="1500" b="1" i="0">
+                <a:solidFill>
+                  <a:srgbClr val="FFFFFF"/>
+                </a:solidFill>
+                <a:latin typeface="Calibri"/>
+              </a:rPr>
+              <a:t>Digitalisation</a:t>
+            </a:r>
+          </a:p>
+        </p:txBody>
+      </p:sp>
+      <p:sp>
+        <p:nvSpPr>
+          <p:cNvPr id="14" name="TextBox 13"/>
+          <p:cNvSpPr txBox="1"/>
+          <p:nvPr/>
+        </p:nvSpPr>
+        <p:spPr>
+          <a:xfrm>
+            <a:off x="4892040" y="3154680"/>
+            <a:ext cx="2377440" cy="457200"/>
+          </a:xfrm>
+          <a:prstGeom prst="rect">
+            <a:avLst/>
+          </a:prstGeom>
+          <a:noFill/>
+        </p:spPr>
+        <p:txBody>
+          <a:bodyPr wrap="square" anchor="t">
+            <a:spAutoFit/>
+          </a:bodyPr>
+          <a:lstStyle/>
+          <a:p>
+            <a:pPr algn="ctr"/>
+            <a:r>
+              <a:rPr sz="1300" b="1" i="0">
+                <a:solidFill>
+                  <a:srgbClr val="5A7D2B"/>
+                </a:solidFill>
+                <a:latin typeface="Calibri"/>
+              </a:rPr>
+              <a:t>Application mobile</a:t>
+            </a:r>
+          </a:p>
+        </p:txBody>
+      </p:sp>
+      <p:sp>
+        <p:nvSpPr>
+          <p:cNvPr id="15" name="Rounded Rectangle 14"/>
+          <p:cNvSpPr/>
+          <p:nvPr/>
+        </p:nvSpPr>
+        <p:spPr>
+          <a:xfrm>
+            <a:off x="7498079" y="2331720"/>
+            <a:ext cx="4023360" cy="3931920"/>
           </a:xfrm>
           <a:prstGeom prst="roundRect">
             <a:avLst>
@@ -11631,14 +11902,14 @@
       </p:sp>
       <p:sp>
         <p:nvSpPr>
-          <p:cNvPr id="10" name="TextBox 9"/>
+          <p:cNvPr id="16" name="TextBox 15"/>
           <p:cNvSpPr txBox="1"/>
           <p:nvPr/>
         </p:nvSpPr>
         <p:spPr>
           <a:xfrm>
-            <a:off x="914400" y="2331720"/>
-            <a:ext cx="4663440" cy="502920"/>
+            <a:off x="7498079" y="2468880"/>
+            <a:ext cx="4023360" cy="502920"/>
           </a:xfrm>
           <a:prstGeom prst="rect">
             <a:avLst/>
@@ -11651,29 +11922,64 @@
           </a:bodyPr>
           <a:lstStyle/>
           <a:p>
-            <a:pPr algn="l"/>
-            <a:r>
-              <a:rPr sz="1700" b="1" i="0">
-                <a:solidFill>
-                  <a:srgbClr val="CC3333"/>
-                </a:solidFill>
-                <a:latin typeface="Calibri"/>
-              </a:rPr>
-              <a:t>⚠  Problèmes actuels</a:t>
-            </a:r>
-          </a:p>
-        </p:txBody>
-      </p:sp>
-      <p:sp>
-        <p:nvSpPr>
-          <p:cNvPr id="11" name="TextBox 10"/>
+            <a:pPr algn="ctr"/>
+            <a:r>
+              <a:rPr sz="2000" b="1" i="0">
+                <a:solidFill>
+                  <a:srgbClr val="FFFFFF"/>
+                </a:solidFill>
+                <a:latin typeface="Calibri"/>
+              </a:rPr>
+              <a:t>Aujourd'hui</a:t>
+            </a:r>
+          </a:p>
+        </p:txBody>
+      </p:sp>
+      <p:sp>
+        <p:nvSpPr>
+          <p:cNvPr id="17" name="TextBox 16"/>
           <p:cNvSpPr txBox="1"/>
           <p:nvPr/>
         </p:nvSpPr>
         <p:spPr>
           <a:xfrm>
-            <a:off x="914400" y="2926080"/>
-            <a:ext cx="4572000" cy="2926080"/>
+            <a:off x="7498079" y="3063240"/>
+            <a:ext cx="4023360" cy="914400"/>
+          </a:xfrm>
+          <a:prstGeom prst="rect">
+            <a:avLst/>
+          </a:prstGeom>
+          <a:noFill/>
+        </p:spPr>
+        <p:txBody>
+          <a:bodyPr wrap="square" anchor="t">
+            <a:spAutoFit/>
+          </a:bodyPr>
+          <a:lstStyle/>
+          <a:p>
+            <a:pPr algn="ctr"/>
+            <a:r>
+              <a:rPr sz="4600" b="0" i="0">
+                <a:solidFill>
+                  <a:srgbClr val="FFFFFF"/>
+                </a:solidFill>
+                <a:latin typeface="Calibri"/>
+              </a:rPr>
+              <a:t>📱</a:t>
+            </a:r>
+          </a:p>
+        </p:txBody>
+      </p:sp>
+      <p:sp>
+        <p:nvSpPr>
+          <p:cNvPr id="18" name="TextBox 17"/>
+          <p:cNvSpPr txBox="1"/>
+          <p:nvPr/>
+        </p:nvSpPr>
+        <p:spPr>
+          <a:xfrm>
+            <a:off x="7863840" y="4206240"/>
+            <a:ext cx="3383280" cy="1920240"/>
           </a:xfrm>
           <a:prstGeom prst="rect">
             <a:avLst/>
@@ -11688,219 +11994,65 @@
           <a:p>
             <a:pPr>
               <a:spcAft>
-                <a:spcPts val="1200"/>
+                <a:spcPts val="1100"/>
               </a:spcAft>
             </a:pPr>
             <a:r>
-              <a:rPr sz="1500">
-                <a:solidFill>
-                  <a:srgbClr val="1B344A"/>
-                </a:solidFill>
-                <a:latin typeface="Calibri"/>
-              </a:rPr>
-              <a:t>•  Saisie lente, sources d'erreurs</a:t>
+              <a:rPr sz="1400">
+                <a:solidFill>
+                  <a:srgbClr val="FFFFFF"/>
+                </a:solidFill>
+                <a:latin typeface="Calibri"/>
+              </a:rPr>
+              <a:t>+  Scan QR / code-barres instantané</a:t>
             </a:r>
           </a:p>
           <a:p>
             <a:pPr>
               <a:spcAft>
-                <a:spcPts val="1200"/>
+                <a:spcPts val="1100"/>
               </a:spcAft>
             </a:pPr>
             <a:r>
-              <a:rPr sz="1500">
-                <a:solidFill>
-                  <a:srgbClr val="1B344A"/>
-                </a:solidFill>
-                <a:latin typeface="Calibri"/>
-              </a:rPr>
-              <a:t>•  Aucun suivi en temps réel</a:t>
+              <a:rPr sz="1400">
+                <a:solidFill>
+                  <a:srgbClr val="FFFFFF"/>
+                </a:solidFill>
+                <a:latin typeface="Calibri"/>
+              </a:rPr>
+              <a:t>+  Photo &amp; reconnaissance par IA</a:t>
             </a:r>
           </a:p>
           <a:p>
             <a:pPr>
               <a:spcAft>
-                <a:spcPts val="1200"/>
+                <a:spcPts val="1100"/>
               </a:spcAft>
             </a:pPr>
             <a:r>
-              <a:rPr sz="1500">
-                <a:solidFill>
-                  <a:srgbClr val="1B344A"/>
-                </a:solidFill>
-                <a:latin typeface="Calibri"/>
-              </a:rPr>
-              <a:t>•  Pas de responsabilisation par agent</a:t>
+              <a:rPr sz="1400">
+                <a:solidFill>
+                  <a:srgbClr val="FFFFFF"/>
+                </a:solidFill>
+                <a:latin typeface="Calibri"/>
+              </a:rPr>
+              <a:t>+  Saisie &amp; validation en un geste</a:t>
             </a:r>
           </a:p>
           <a:p>
             <a:pPr>
               <a:spcAft>
-                <a:spcPts val="1200"/>
+                <a:spcPts val="1100"/>
               </a:spcAft>
             </a:pPr>
             <a:r>
-              <a:rPr sz="1500">
-                <a:solidFill>
-                  <a:srgbClr val="1B344A"/>
-                </a:solidFill>
-                <a:latin typeface="Calibri"/>
-              </a:rPr>
-              <a:t>•  Pas de preuve photo des biens</a:t>
-            </a:r>
-          </a:p>
-          <a:p>
-            <a:pPr>
-              <a:spcAft>
-                <a:spcPts val="1200"/>
-              </a:spcAft>
-            </a:pPr>
-            <a:r>
-              <a:rPr sz="1500">
-                <a:solidFill>
-                  <a:srgbClr val="1B344A"/>
-                </a:solidFill>
-                <a:latin typeface="Calibri"/>
-              </a:rPr>
-              <a:t>•  Rapprochement comptable fastidieux</a:t>
-            </a:r>
-          </a:p>
-        </p:txBody>
-      </p:sp>
-      <p:sp>
-        <p:nvSpPr>
-          <p:cNvPr id="12" name="TextBox 11"/>
-          <p:cNvSpPr txBox="1"/>
-          <p:nvPr/>
-        </p:nvSpPr>
-        <p:spPr>
-          <a:xfrm>
-            <a:off x="6583680" y="2331720"/>
-            <a:ext cx="4663440" cy="502920"/>
-          </a:xfrm>
-          <a:prstGeom prst="rect">
-            <a:avLst/>
-          </a:prstGeom>
-          <a:noFill/>
-        </p:spPr>
-        <p:txBody>
-          <a:bodyPr wrap="square" anchor="t">
-            <a:spAutoFit/>
-          </a:bodyPr>
-          <a:lstStyle/>
-          <a:p>
-            <a:pPr algn="l"/>
-            <a:r>
-              <a:rPr sz="1700" b="1" i="0">
+              <a:rPr sz="1400">
                 <a:solidFill>
                   <a:srgbClr val="FFFFFF"/>
                 </a:solidFill>
                 <a:latin typeface="Calibri"/>
               </a:rPr>
-              <a:t>✓  Solution proposée</a:t>
-            </a:r>
-          </a:p>
-        </p:txBody>
-      </p:sp>
-      <p:sp>
-        <p:nvSpPr>
-          <p:cNvPr id="13" name="TextBox 12"/>
-          <p:cNvSpPr txBox="1"/>
-          <p:nvPr/>
-        </p:nvSpPr>
-        <p:spPr>
-          <a:xfrm>
-            <a:off x="6583680" y="2926080"/>
-            <a:ext cx="4572000" cy="2926080"/>
-          </a:xfrm>
-          <a:prstGeom prst="rect">
-            <a:avLst/>
-          </a:prstGeom>
-          <a:noFill/>
-        </p:spPr>
-        <p:txBody>
-          <a:bodyPr wrap="square">
-            <a:spAutoFit/>
-          </a:bodyPr>
-          <a:lstStyle/>
-          <a:p>
-            <a:pPr>
-              <a:spcAft>
-                <a:spcPts val="1200"/>
-              </a:spcAft>
-            </a:pPr>
-            <a:r>
-              <a:rPr sz="1500">
-                <a:solidFill>
-                  <a:srgbClr val="FFFFFF"/>
-                </a:solidFill>
-                <a:latin typeface="Calibri"/>
-              </a:rPr>
-              <a:t>•  Application mobile Android native</a:t>
-            </a:r>
-          </a:p>
-          <a:p>
-            <a:pPr>
-              <a:spcAft>
-                <a:spcPts val="1200"/>
-              </a:spcAft>
-            </a:pPr>
-            <a:r>
-              <a:rPr sz="1500">
-                <a:solidFill>
-                  <a:srgbClr val="FFFFFF"/>
-                </a:solidFill>
-                <a:latin typeface="Calibri"/>
-              </a:rPr>
-              <a:t>•  Scan QR code &amp; code-barres</a:t>
-            </a:r>
-          </a:p>
-          <a:p>
-            <a:pPr>
-              <a:spcAft>
-                <a:spcPts val="1200"/>
-              </a:spcAft>
-            </a:pPr>
-            <a:r>
-              <a:rPr sz="1500">
-                <a:solidFill>
-                  <a:srgbClr val="FFFFFF"/>
-                </a:solidFill>
-                <a:latin typeface="Calibri"/>
-              </a:rPr>
-              <a:t>•  Reconnaissance d'objet par IA</a:t>
-            </a:r>
-          </a:p>
-          <a:p>
-            <a:pPr>
-              <a:spcAft>
-                <a:spcPts val="1200"/>
-              </a:spcAft>
-            </a:pPr>
-            <a:r>
-              <a:rPr sz="1500">
-                <a:solidFill>
-                  <a:srgbClr val="FFFFFF"/>
-                </a:solidFill>
-                <a:latin typeface="Calibri"/>
-              </a:rPr>
-              <a:t>•  Photo &amp; validation des biens</a:t>
-            </a:r>
-          </a:p>
-          <a:p>
-            <a:pPr>
-              <a:spcAft>
-                <a:spcPts val="1200"/>
-              </a:spcAft>
-            </a:pPr>
-            <a:r>
-              <a:rPr sz="1500">
-                <a:solidFill>
-                  <a:srgbClr val="FFFFFF"/>
-                </a:solidFill>
-                <a:latin typeface="Calibri"/>
-              </a:rPr>
-              <a:t>•  Export Excel / PDF instantané</a:t>
+              <a:t>+  Export Excel / PDF immédiat</a:t>
             </a:r>
           </a:p>
         </p:txBody>

</xml_diff>